<commit_message>
Add deterministic QA validation decks
</commit_message>
<xml_diff>
--- a/testdata/corpus/alignment/alignment-role-guard-boundary.pptx
+++ b/testdata/corpus/alignment/alignment-role-guard-boundary.pptx
@@ -1,6 +1,7 @@
 
 <file path=ppt/presentation.xml><?xml version="1.0" encoding="utf-8"?>
 <p:presentation xmlns:a="http://schemas.openxmlformats.org/drawingml/2006/main" xmlns:p="http://schemas.openxmlformats.org/presentationml/2006/main" xmlns:r="http://schemas.openxmlformats.org/officeDocument/2006/relationships">
+  <p:sldSz cx="9144000" cy="6858000"/>
   <p:sldIdLst>
     <p:sldId id="256" r:id="rId1"/>
   </p:sldIdLst>
@@ -19,15 +20,23 @@
       <p:grpSpPr/>
       <p:sp>
         <p:nvSpPr>
-          <p:cNvPr id="2" name="Title Alignment Boundary"/>
+          <p:cNvPr id="2" name="Title 2"/>
           <p:cNvSpPr/>
           <p:nvPr>
             <p:ph type="title"/>
           </p:nvPr>
         </p:nvSpPr>
-        <p:spPr/>
+        <p:spPr>
+          <a:xfrm>
+            <a:off x="457200" y="274320"/>
+            <a:ext cx="8229600" cy="685800"/>
+          </a:xfrm>
+          <a:prstGeom prst="rect">
+            <a:avLst/>
+          </a:prstGeom>
+        </p:spPr>
         <p:txBody>
-          <a:bodyPr/>
+          <a:bodyPr wrap="square"/>
           <a:lstStyle/>
           <a:p>
             <a:pPr>
@@ -35,7 +44,7 @@
             </a:pPr>
             <a:r>
               <a:rPr sz="2800">
-                <a:latin typeface="Calibri"/>
+                <a:latin typeface="Aptos"/>
               </a:rPr>
               <a:t>Boundary: Alignment Roles</a:t>
             </a:r>
@@ -44,60 +53,83 @@
       </p:sp>
       <p:sp>
         <p:nvSpPr>
-          <p:cNvPr id="3" name="Boundary Alignment Body"/>
+          <p:cNvPr id="3" name="Body 3"/>
           <p:cNvSpPr/>
           <p:nvPr/>
         </p:nvSpPr>
-        <p:spPr/>
+        <p:spPr>
+          <a:xfrm>
+            <a:off x="685800" y="1295400"/>
+            <a:ext cx="7772400" cy="4114800"/>
+          </a:xfrm>
+          <a:prstGeom prst="rect">
+            <a:avLst/>
+          </a:prstGeom>
+        </p:spPr>
         <p:txBody>
-          <a:bodyPr/>
+          <a:bodyPr wrap="square"/>
           <a:lstStyle/>
           <a:p>
             <a:pPr algn="l">
+              <a:spcAft>
+                <a:spcPts val="1200"/>
+              </a:spcAft>
               <a:buNone/>
             </a:pPr>
             <a:r>
               <a:rPr sz="2000">
-                <a:latin typeface="Calibri"/>
+                <a:latin typeface="Aptos"/>
               </a:rPr>
               <a:t>Alignment boundary baseline one.</a:t>
             </a:r>
           </a:p>
           <a:p>
             <a:pPr algn="ctr">
+              <a:spcAft>
+                <a:spcPts val="1200"/>
+              </a:spcAft>
               <a:buNone/>
             </a:pPr>
             <a:r>
               <a:rPr sz="2800">
-                <a:latin typeface="Calibri"/>
+                <a:latin typeface="Aptos"/>
               </a:rPr>
               <a:t>Boundary centered role must stay centered.</a:t>
             </a:r>
           </a:p>
           <a:p>
             <a:pPr algn="l">
+              <a:spcAft>
+                <a:spcPts val="1200"/>
+              </a:spcAft>
               <a:buNone/>
             </a:pPr>
             <a:r>
               <a:rPr sz="2000">
-                <a:latin typeface="Calibri"/>
+                <a:latin typeface="Aptos"/>
               </a:rPr>
               <a:t>Alignment boundary baseline two.</a:t>
             </a:r>
           </a:p>
           <a:p>
             <a:pPr algn="l">
+              <a:spcAft>
+                <a:spcPts val="1200"/>
+              </a:spcAft>
               <a:buNone/>
             </a:pPr>
             <a:r>
               <a:rPr sz="2000">
-                <a:latin typeface="Calibri"/>
+                <a:latin typeface="Aptos"/>
               </a:rPr>
               <a:t>Alignment boundary baseline three.</a:t>
             </a:r>
           </a:p>
           <a:p>
             <a:pPr algn="r">
+              <a:spcAft>
+                <a:spcPts val="1200"/>
+              </a:spcAft>
               <a:buNone/>
             </a:pPr>
             <a:r>
@@ -109,11 +141,14 @@
           </a:p>
           <a:p>
             <a:pPr algn="l">
+              <a:spcAft>
+                <a:spcPts val="1200"/>
+              </a:spcAft>
               <a:buNone/>
             </a:pPr>
             <a:r>
               <a:rPr sz="2000">
-                <a:latin typeface="Calibri"/>
+                <a:latin typeface="Aptos"/>
               </a:rPr>
               <a:t>Alignment boundary baseline four.</a:t>
             </a:r>

</xml_diff>